<commit_message>
Slide 6: add GitHub repository link
Co-Authored-By: Claude Fable 5.1 <noreply@anthropic.com>
</commit_message>
<xml_diff>
--- a/deliverables/SIH_HACKTIDE_PS_26126.pptx
+++ b/deliverables/SIH_HACKTIDE_PS_26126.pptx
@@ -14413,7 +14413,7 @@
       </p:sp>
       <p:pic>
         <p:nvPicPr>
-          <p:cNvPr id="9" name="Image 1" descr="/Users/sandillakiran/SIH-126/prototype/output/03_unknown_full.png">    </p:cNvPr>
+          <p:cNvPr id="9" name="Image 1" descr="/Users/sandillakiran/SIH-126/code/output/03_unknown_full.png">    </p:cNvPr>
           <p:cNvPicPr>
             <a:picLocks noChangeAspect="1"/>
           </p:cNvPicPr>
@@ -16717,8 +16717,8 @@
         </p:nvSpPr>
         <p:spPr>
           <a:xfrm>
-            <a:off x="5074920" y="1700784"/>
-            <a:ext cx="3749040" cy="292608"/>
+            <a:off x="5074920" y="1682496"/>
+            <a:ext cx="3749040" cy="164592"/>
           </a:xfrm>
           <a:prstGeom prst="rect">
             <a:avLst/>
@@ -16742,7 +16742,7 @@
                 <a:ea typeface="Arial" pitchFamily="34" charset="-122"/>
                 <a:cs typeface="Arial" pitchFamily="34" charset="-120"/>
               </a:rPr>
-              <a:t>Complete repository — simulator, perception, risk map, planner, dashboard, evaluation harness  ·  [GitHub link – add before submission]</a:t>
+              <a:t>Complete repository — simulator, risk map, planner, evaluation harness, deck generator</a:t>
             </a:r>
             <a:endParaRPr lang="en-US" sz="700" dirty="0"/>
           </a:p>
@@ -16750,7 +16750,55 @@
       </p:sp>
       <p:sp>
         <p:nvSpPr>
-          <p:cNvPr id="22" name="Text 15"/>
+          <p:cNvPr id="22" name="Text 15">
+            <a:hlinkClick r:id="rId5" tooltip=""/>
+          </p:cNvPr>
+          <p:cNvSpPr txBox="1"/>
+          <p:nvPr/>
+        </p:nvSpPr>
+        <p:spPr>
+          <a:xfrm>
+            <a:off x="5074920" y="1847088"/>
+            <a:ext cx="3749040" cy="164592"/>
+          </a:xfrm>
+          <a:prstGeom prst="rect">
+            <a:avLst/>
+          </a:prstGeom>
+          <a:noFill/>
+          <a:ln/>
+        </p:spPr>
+        <p:txBody>
+          <a:bodyPr wrap="square" lIns="0" tIns="0" rIns="0" bIns="0" rtlCol="0" anchor="t"/>
+          <a:lstStyle/>
+          <a:p>
+            <a:pPr indent="0" marL="0">
+              <a:buNone/>
+            </a:pPr>
+            <a:r>
+              <a:rPr lang="en-US" sz="800" b="1" u="sng" dirty="0">
+                <a:solidFill>
+                  <a:srgbClr val="1E2761"/>
+                </a:solidFill>
+                <a:latin typeface="Arial" pitchFamily="34" charset="0"/>
+                <a:ea typeface="Arial" pitchFamily="34" charset="-122"/>
+                <a:cs typeface="Arial" pitchFamily="34" charset="-120"/>
+                <a:hlinkClick r:id="rId5" invalidUrl="" action="" tgtFrame="" tooltip="" history="1" highlightClick="0" endSnd="0">
+                  <a:extLst>
+                    <a:ext uri="{A12FA001-AC4F-418D-AE19-62706E023703}">
+                      <ahyp:hlinkClr xmlns:ahyp="http://schemas.microsoft.com/office/drawing/2018/hyperlinkcolor" val="tx"/>
+                    </a:ext>
+                  </a:extLst>
+                </a:hlinkClick>
+              </a:rPr>
+              <a:t>https://github.com/kiransandilla/SIH_PS_126</a:t>
+            </a:r>
+            <a:endParaRPr lang="en-US" sz="800" dirty="0"/>
+          </a:p>
+        </p:txBody>
+      </p:sp>
+      <p:sp>
+        <p:nvSpPr>
+          <p:cNvPr id="23" name="Text 16"/>
           <p:cNvSpPr txBox="1"/>
           <p:nvPr/>
         </p:nvSpPr>
@@ -16789,7 +16837,7 @@
       </p:sp>
       <p:sp>
         <p:nvSpPr>
-          <p:cNvPr id="23" name="Text 16"/>
+          <p:cNvPr id="24" name="Text 17"/>
           <p:cNvSpPr txBox="1"/>
           <p:nvPr/>
         </p:nvSpPr>

</xml_diff>